<commit_message>
RESHIPPED (task130): round 1 restored by the author's decision after round 2 was sent back
Every task130 file back to 9bf3cbc ($784,000); round 2 ($587,000, the Early
Resolution Program's class experience) recorded in the design note, the card's
lineage, pipeline.json and the ledger's earlier architectures. Nine Three rules
lines from the 10/10 audit added true to round 1; precut.py 49 checks, 0 WARN.

Co-Authored-By: Claude Opus 5.5 <noreply@anthropic.com>
Claude-Session: https://claude.ai/code/session_01A6XcFx5t62c7gPi1bBKcVi
</commit_message>
<xml_diff>
--- a/task130/golden/trustees_paper_2027.pptx
+++ b/task130/golden/trustees_paper_2027.pptx
@@ -3117,7 +3117,7 @@
                   <a:srgbClr val="1F2F3F"/>
                 </a:solidFill>
               </a:rPr>
-              <a:t>2027 contribution to the Trust: $587,000</a:t>
+              <a:t>2027 contribution to the Trust: $784,000</a:t>
             </a:r>
           </a:p>
         </p:txBody>
@@ -3150,7 +3150,7 @@
                   <a:srgbClr val="5A6672"/>
                 </a:solidFill>
               </a:rPr>
-              <a:t>Recommended: the Participating Entities contribute $587,000 for 2027, the expected cost of the 10.2 Claims expected to be first made against the Trust in its first Plan Year</a:t>
+              <a:t>Recommended: the Participating Entities contribute $784,000 for 2027, the expected cost of the Claims that will be first made against the Trust in its first Plan Year</a:t>
             </a:r>
           </a:p>
         </p:txBody>
@@ -3290,7 +3290,7 @@
                             <a:srgbClr val="FFFFFF"/>
                           </a:solidFill>
                         </a:rPr>
-                        <a:t>Share</a:t>
+                        <a:t>Expected Claims</a:t>
                       </a:r>
                     </a:p>
                   </a:txBody>
@@ -3312,7 +3312,7 @@
                             <a:srgbClr val="FFFFFF"/>
                           </a:solidFill>
                         </a:rPr>
-                        <a:t>Pays ($)</a:t>
+                        <a:t>Expected cost ($)</a:t>
                       </a:r>
                     </a:p>
                   </a:txBody>
@@ -3378,7 +3378,7 @@
                             <a:srgbClr val="1F2F3F"/>
                           </a:solidFill>
                         </a:rPr>
-                        <a:t>113.4</a:t>
+                        <a:t>100.2</a:t>
                       </a:r>
                     </a:p>
                   </a:txBody>
@@ -3400,7 +3400,7 @@
                             <a:srgbClr val="1F2F3F"/>
                           </a:solidFill>
                         </a:rPr>
-                        <a:t>18.9%</a:t>
+                        <a:t>2.9</a:t>
                       </a:r>
                     </a:p>
                   </a:txBody>
@@ -3422,7 +3422,7 @@
                             <a:srgbClr val="1F2F3F"/>
                           </a:solidFill>
                         </a:rPr>
-                        <a:t>111,000</a:t>
+                        <a:t>227,000</a:t>
                       </a:r>
                     </a:p>
                   </a:txBody>
@@ -3488,7 +3488,7 @@
                             <a:srgbClr val="1F2F3F"/>
                           </a:solidFill>
                         </a:rPr>
-                        <a:t>205.5</a:t>
+                        <a:t>175.6</a:t>
                       </a:r>
                     </a:p>
                   </a:txBody>
@@ -3510,7 +3510,7 @@
                             <a:srgbClr val="1F2F3F"/>
                           </a:solidFill>
                         </a:rPr>
-                        <a:t>34.3%</a:t>
+                        <a:t>4.6</a:t>
                       </a:r>
                     </a:p>
                   </a:txBody>
@@ -3532,7 +3532,7 @@
                             <a:srgbClr val="1F2F3F"/>
                           </a:solidFill>
                         </a:rPr>
-                        <a:t>201,000</a:t>
+                        <a:t>336,000</a:t>
                       </a:r>
                     </a:p>
                   </a:txBody>
@@ -3598,7 +3598,7 @@
                             <a:srgbClr val="1F2F3F"/>
                           </a:solidFill>
                         </a:rPr>
-                        <a:t>265.4</a:t>
+                        <a:t>264.9</a:t>
                       </a:r>
                     </a:p>
                   </a:txBody>
@@ -3620,7 +3620,7 @@
                             <a:srgbClr val="1F2F3F"/>
                           </a:solidFill>
                         </a:rPr>
-                        <a:t>44.2%</a:t>
+                        <a:t>3.9</a:t>
                       </a:r>
                     </a:p>
                   </a:txBody>
@@ -3642,7 +3642,7 @@
                             <a:srgbClr val="1F2F3F"/>
                           </a:solidFill>
                         </a:rPr>
-                        <a:t>260,000</a:t>
+                        <a:t>214,000</a:t>
                       </a:r>
                     </a:p>
                   </a:txBody>
@@ -3708,7 +3708,7 @@
                             <a:srgbClr val="1F2F3F"/>
                           </a:solidFill>
                         </a:rPr>
-                        <a:t>15.6</a:t>
+                        <a:t>15.1</a:t>
                       </a:r>
                     </a:p>
                   </a:txBody>
@@ -3730,7 +3730,7 @@
                             <a:srgbClr val="1F2F3F"/>
                           </a:solidFill>
                         </a:rPr>
-                        <a:t>2.6%</a:t>
+                        <a:t>0.1</a:t>
                       </a:r>
                     </a:p>
                   </a:txBody>
@@ -3752,7 +3752,7 @@
                             <a:srgbClr val="1F2F3F"/>
                           </a:solidFill>
                         </a:rPr>
-                        <a:t>15,000</a:t>
+                        <a:t>7,000</a:t>
                       </a:r>
                     </a:p>
                   </a:txBody>
@@ -3818,7 +3818,7 @@
                             <a:srgbClr val="1F2F3F"/>
                           </a:solidFill>
                         </a:rPr>
-                        <a:t>599.9</a:t>
+                        <a:t>555.8</a:t>
                       </a:r>
                     </a:p>
                   </a:txBody>
@@ -3840,7 +3840,7 @@
                             <a:srgbClr val="1F2F3F"/>
                           </a:solidFill>
                         </a:rPr>
-                        <a:t>100.0%</a:t>
+                        <a:t>11.5</a:t>
                       </a:r>
                     </a:p>
                   </a:txBody>
@@ -3862,7 +3862,7 @@
                             <a:srgbClr val="1F2F3F"/>
                           </a:solidFill>
                         </a:rPr>
-                        <a:t>587,000</a:t>
+                        <a:t>784,000</a:t>
                       </a:r>
                     </a:p>
                   </a:txBody>
@@ -3905,7 +3905,7 @@
                   <a:srgbClr val="5A6672"/>
                 </a:solidFill>
               </a:rPr>
-              <a:t>The Trust is claims-made and each entity's Transition Date is its Retroactive Date: in 2027 it pays only for Claims made by 31 December from incidents after the entity joined, so the first year catches mostly the requests patients bring within months of their care.</a:t>
+              <a:t>Each entity joins on the day its occurrence policy expires, and the Trust is claims-made with each entity's Transition Date as its Retroactive Date: in 2027 it pays only for Claims made by 31 December from incidents after the entity joined.</a:t>
             </a:r>
           </a:p>
           <a:p>
@@ -3915,7 +3915,7 @@
                   <a:srgbClr val="5A6672"/>
                 </a:solidFill>
               </a:rPr>
-              <a:t>From its Transition Date every entity's patients can come through the Early Resolution Program, which has served only Tolliver Falls and Alderwick. The window is costed on those hospitals' experience, one rate per specialty class for all four entities; on the System's pooled experience it would be about half.</a:t>
+              <a:t>In the System's 2017 to 2024 experience the Claims made within a few months of their incident settled small, and most of the cost sits in Claims made a year or more after it. Costed claim by claim on that experience, the first year is a fraction of a mature year's cost.</a:t>
             </a:r>
           </a:p>
           <a:p>
@@ -3925,7 +3925,7 @@
                   <a:srgbClr val="5A6672"/>
                 </a:solidFill>
               </a:rPr>
-              <a:t>Shares follow the 2027 exposure (funding policy section 2). No provision for expenses, investment income, excess insurance or margin (3.6).</a:t>
+              <a:t>No provision for expenses, investment income, excess insurance or margin (funding policy 3.5).</a:t>
             </a:r>
           </a:p>
         </p:txBody>
@@ -4099,7 +4099,7 @@
                   <a:srgbClr val="5A6672"/>
                 </a:solidFill>
               </a:rPr>
-              <a:t>Source: risk management claims register valued 30 September 2026 (Tolliver Falls and Alderwick incidents 2017 to 2024, trended at 5.0% a year); clinician staffing plan 2027. Each entity counts from its Transition Date.</a:t>
+              <a:t>Source: risk management claims register valued 30 September 2026 (incidents 2017 to 2024, trended at 5.0% a year); clinician staffing plan 2027. Each entity counts from its Transition Date.</a:t>
             </a:r>
           </a:p>
         </p:txBody>

</xml_diff>

<commit_message>
PAUSED (task130): rule 3 rework 3b (second layer), stage 3 green
Round 3b adds a second analytical layer: the Early Resolution Program's
disclosure settlements began at each entity between January and July 2019
(none before, steady after), so the 2027 window is costed on each entity's
experience from its first settlement, each Claim at its own report lag.
Call $1,250,000 ($1,281,536, SE $65,916); the loss-weighted step factor on
the whole 2016 to 2024 experience files $1,000,000 ($961,261, 1.28 bins).
Funding policy 3.1 files the estimand as Claims as they will arise and be
made in the Plan Year; 3.3 states the experience the trust holds; claims
seed 3006. Resume at stage 4: a fresh reader and judge.

Co-Authored-By: Claude Opus 5.5 <noreply@anthropic.com>
Claude-Session: https://claude.ai/code/session_01A6XcFx5t62c7gPi1bBKcVi
</commit_message>
<xml_diff>
--- a/task130/golden/trustees_paper_2027.pptx
+++ b/task130/golden/trustees_paper_2027.pptx
@@ -3583,7 +3583,7 @@
                   <a:srgbClr val="5A6672"/>
                 </a:solidFill>
               </a:rPr>
-              <a:t>Those are the Claims the System's experience makes within the year: harm disclosed and settled within weeks of the care, which is costly, and program requests a few months on, which settle small. The demands and suits that carry most of the experience's cost come a year or more after the care, after 2027 for every entity.</a:t>
+              <a:t>Those are the Claims the System's experience makes within the year: harm the care team disclosed, settled within weeks of the care, which is costly, and program requests a few months on, which settle small. The demands and suits that carry most of the experience's cost come a year or more after the care, after 2027 for every entity.</a:t>
             </a:r>
           </a:p>
           <a:p>
@@ -3593,7 +3593,7 @@
                   <a:srgbClr val="5A6672"/>
                 </a:solidFill>
               </a:rPr>
-              <a:t>Each 2016 to 2024 experience Claim was costed at its own delay from incident to first making against the days each entity is in the Trust in 2027, within its specialty class.</a:t>
+              <a:t>The disclosure settlements began at each entity in 2019 and have run every year since, so the window is costed on each entity's experience from its first settlement to 2024, each Claim at its own delay from incident to first making against the days each entity is in the Trust in 2027, within its specialty class. The 2016 to 2018 years have none and would understate 2027.</a:t>
             </a:r>
           </a:p>
           <a:p>

</xml_diff>